<commit_message>
docs(progress_report): 연말 보고 pptx 에 FTP 접속과 10월 개선을 더합니다
md · html (5e7b00df) 과 같은 내용을 덱에 반영합니다. 7장에서 9장이 됩니다.
- 표지 날짜에 갱신일 2026-10-20 을 붙입니다.
- 요약 슬라이드에 5번째 행(FTP 접속 · Metrology 엔지니어)을 더합니다.
- 통합 조회 슬라이드의 장비 상태 카드에 FTP 접속을 넣습니다.
- 새 슬라이드 7: FTP 접속 (대상 팀, 탐색 · 다운로드 · 링크 공유 · 안정성).
- 새 슬라이드 8: 10월 데이터 정확도 개선 (디바이스 통계, 횡전개, Recipe 현황,
  AFM · 운영).
- 이후 과제에 VeritySEM · Provision 사전 조사와 Recipe 일괄 복사 도구를 더합니다.

기존 슬라이드를 복제해 XML 을 고쳤으므로 디자인은 그대로입니다.

Co-Authored-By: Claude Opus 5.5 <noreply@anthropic.com>
</commit_message>
<xml_diff>
--- a/docs/progress_report/skewnono_year_end_report_2026.pptx
+++ b/docs/progress_report/skewnono_year_end_report_2026.pptx
@@ -11,6 +11,8 @@
     <p:sldId id="259" r:id="rId5"/>
     <p:sldId id="260" r:id="rId6"/>
     <p:sldId id="261" r:id="rId7"/>
+    <p:sldId id="263" r:id="rId14"/>
+    <p:sldId id="264" r:id="rId15"/>
     <p:sldId id="262" r:id="rId8"/>
   </p:sldIdLst>
   <p:notesMasterIdLst>
@@ -1957,7 +1959,7 @@
                   <a:schemeClr val="accent5"/>
                 </a:solidFill>
               </a:rPr>
-              <a:t>2026-10-09</a:t>
+              <a:t>2026-10-09 · 갱신 2026-10-20</a:t>
             </a:r>
             <a:endParaRPr lang="en-US" sz="1400" dirty="0"/>
           </a:p>
@@ -2439,7 +2441,7 @@
         </p:nvSpPr>
         <p:spPr>
           <a:xfrm>
-            <a:off x="548640" y="3977640"/>
+            <a:off x="548640" y="3886200"/>
             <a:ext cx="420624" cy="420624"/>
           </a:xfrm>
           <a:prstGeom prst="ellipse">
@@ -2477,7 +2479,7 @@
         </p:nvSpPr>
         <p:spPr>
           <a:xfrm>
-            <a:off x="1143000" y="3977640"/>
+            <a:off x="1143000" y="3886200"/>
             <a:ext cx="2377440" cy="420624"/>
           </a:xfrm>
           <a:prstGeom prst="rect">
@@ -2513,7 +2515,7 @@
         </p:nvSpPr>
         <p:spPr>
           <a:xfrm>
-            <a:off x="3566160" y="3977640"/>
+            <a:off x="3566160" y="3886200"/>
             <a:ext cx="2651760" cy="420624"/>
           </a:xfrm>
           <a:prstGeom prst="rect">
@@ -2549,7 +2551,7 @@
         </p:nvSpPr>
         <p:spPr>
           <a:xfrm>
-            <a:off x="6263640" y="3977640"/>
+            <a:off x="6263640" y="3886200"/>
             <a:ext cx="5376672" cy="420624"/>
           </a:xfrm>
           <a:prstGeom prst="rect">
@@ -2585,7 +2587,7 @@
         </p:nvSpPr>
         <p:spPr>
           <a:xfrm>
-            <a:off x="548640" y="4544568"/>
+            <a:off x="548640" y="4361688"/>
             <a:ext cx="420624" cy="420624"/>
           </a:xfrm>
           <a:prstGeom prst="ellipse">
@@ -2623,7 +2625,7 @@
         </p:nvSpPr>
         <p:spPr>
           <a:xfrm>
-            <a:off x="1143000" y="4544568"/>
+            <a:off x="1143000" y="4361688"/>
             <a:ext cx="2377440" cy="420624"/>
           </a:xfrm>
           <a:prstGeom prst="rect">
@@ -2659,7 +2661,7 @@
         </p:nvSpPr>
         <p:spPr>
           <a:xfrm>
-            <a:off x="3566160" y="4544568"/>
+            <a:off x="3566160" y="4361688"/>
             <a:ext cx="2651760" cy="420624"/>
           </a:xfrm>
           <a:prstGeom prst="rect">
@@ -2695,7 +2697,7 @@
         </p:nvSpPr>
         <p:spPr>
           <a:xfrm>
-            <a:off x="6263640" y="4544568"/>
+            <a:off x="6263640" y="4361688"/>
             <a:ext cx="5376672" cy="420624"/>
           </a:xfrm>
           <a:prstGeom prst="rect">
@@ -2731,7 +2733,7 @@
         </p:nvSpPr>
         <p:spPr>
           <a:xfrm>
-            <a:off x="548640" y="5111496"/>
+            <a:off x="548640" y="4837176"/>
             <a:ext cx="420624" cy="420624"/>
           </a:xfrm>
           <a:prstGeom prst="ellipse">
@@ -2769,7 +2771,7 @@
         </p:nvSpPr>
         <p:spPr>
           <a:xfrm>
-            <a:off x="1143000" y="5111496"/>
+            <a:off x="1143000" y="4837176"/>
             <a:ext cx="2377440" cy="420624"/>
           </a:xfrm>
           <a:prstGeom prst="rect">
@@ -2805,7 +2807,7 @@
         </p:nvSpPr>
         <p:spPr>
           <a:xfrm>
-            <a:off x="3566160" y="5111496"/>
+            <a:off x="3566160" y="4837176"/>
             <a:ext cx="2651760" cy="420624"/>
           </a:xfrm>
           <a:prstGeom prst="rect">
@@ -2841,7 +2843,7 @@
         </p:nvSpPr>
         <p:spPr>
           <a:xfrm>
-            <a:off x="6263640" y="5111496"/>
+            <a:off x="6263640" y="4837176"/>
             <a:ext cx="5376672" cy="420624"/>
           </a:xfrm>
           <a:prstGeom prst="rect">
@@ -2877,7 +2879,7 @@
         </p:nvSpPr>
         <p:spPr>
           <a:xfrm>
-            <a:off x="548640" y="5678424"/>
+            <a:off x="548640" y="5312664"/>
             <a:ext cx="420624" cy="420624"/>
           </a:xfrm>
           <a:prstGeom prst="ellipse">
@@ -2915,7 +2917,7 @@
         </p:nvSpPr>
         <p:spPr>
           <a:xfrm>
-            <a:off x="1143000" y="5678424"/>
+            <a:off x="1143000" y="5312664"/>
             <a:ext cx="2377440" cy="420624"/>
           </a:xfrm>
           <a:prstGeom prst="rect">
@@ -2951,7 +2953,7 @@
         </p:nvSpPr>
         <p:spPr>
           <a:xfrm>
-            <a:off x="3566160" y="5678424"/>
+            <a:off x="3566160" y="5312664"/>
             <a:ext cx="2651760" cy="420624"/>
           </a:xfrm>
           <a:prstGeom prst="rect">
@@ -2987,7 +2989,7 @@
         </p:nvSpPr>
         <p:spPr>
           <a:xfrm>
-            <a:off x="6263640" y="5678424"/>
+            <a:off x="6263640" y="5312664"/>
             <a:ext cx="5376672" cy="420624"/>
           </a:xfrm>
           <a:prstGeom prst="rect">
@@ -3057,6 +3059,152 @@
               <a:t>2</a:t>
             </a:fld>
             <a:endParaRPr lang="en-US"/>
+          </a:p>
+        </p:txBody>
+      </p:sp>
+      <p:sp>
+        <p:nvSpPr>
+          <p:cNvPr id="31" name="row5-0"/>
+          <p:cNvSpPr/>
+          <p:nvPr/>
+        </p:nvSpPr>
+        <p:spPr>
+          <a:xfrm>
+            <a:off x="548640" y="5788152"/>
+            <a:ext cx="420624" cy="420624"/>
+          </a:xfrm>
+          <a:prstGeom prst="ellipse">
+            <a:avLst/>
+          </a:prstGeom>
+          <a:solidFill>
+            <a:schemeClr val="accent1"/>
+          </a:solidFill>
+          <a:ln/>
+        </p:spPr>
+        <p:txBody>
+          <a:bodyPr wrap="square" lIns="0" tIns="0" rIns="0" bIns="0" rtlCol="0" anchor="ctr"/>
+          <a:lstStyle/>
+          <a:p>
+            <a:pPr algn="ctr" indent="0" marL="0">
+              <a:buNone/>
+            </a:pPr>
+            <a:r>
+              <a:rPr lang="en-US" sz="1400" b="1" dirty="0">
+                <a:solidFill>
+                  <a:schemeClr val="bg1"/>
+                </a:solidFill>
+              </a:rPr>
+              <a:t>5</a:t>
+            </a:r>
+            <a:endParaRPr lang="en-US" sz="1400" dirty="0"/>
+          </a:p>
+        </p:txBody>
+      </p:sp>
+      <p:sp>
+        <p:nvSpPr>
+          <p:cNvPr id="32" name="row5-1"/>
+          <p:cNvSpPr txBox="1"/>
+          <p:nvPr/>
+        </p:nvSpPr>
+        <p:spPr>
+          <a:xfrm>
+            <a:off x="1143000" y="5788152"/>
+            <a:ext cx="2377440" cy="420624"/>
+          </a:xfrm>
+          <a:prstGeom prst="rect">
+            <a:avLst/>
+          </a:prstGeom>
+          <a:noFill/>
+          <a:ln/>
+        </p:spPr>
+        <p:txBody>
+          <a:bodyPr wrap="square" lIns="0" tIns="0" rIns="0" bIns="0" rtlCol="0" anchor="ctr"/>
+          <a:lstStyle/>
+          <a:p>
+            <a:pPr indent="0" marL="0">
+              <a:buNone/>
+            </a:pPr>
+            <a:r>
+              <a:rPr lang="en-US" sz="1600" b="1" dirty="0">
+                <a:solidFill>
+                  <a:schemeClr val="tx1"/>
+                </a:solidFill>
+              </a:rPr>
+              <a:t>FTP 접속</a:t>
+            </a:r>
+            <a:endParaRPr lang="en-US" sz="1600" dirty="0"/>
+          </a:p>
+        </p:txBody>
+      </p:sp>
+      <p:sp>
+        <p:nvSpPr>
+          <p:cNvPr id="33" name="row5-2"/>
+          <p:cNvSpPr txBox="1"/>
+          <p:nvPr/>
+        </p:nvSpPr>
+        <p:spPr>
+          <a:xfrm>
+            <a:off x="3566160" y="5788152"/>
+            <a:ext cx="2651760" cy="420624"/>
+          </a:xfrm>
+          <a:prstGeom prst="rect">
+            <a:avLst/>
+          </a:prstGeom>
+          <a:noFill/>
+          <a:ln/>
+        </p:spPr>
+        <p:txBody>
+          <a:bodyPr wrap="square" lIns="0" tIns="0" rIns="0" bIns="0" rtlCol="0" anchor="ctr"/>
+          <a:lstStyle/>
+          <a:p>
+            <a:pPr indent="0" marL="0">
+              <a:buNone/>
+            </a:pPr>
+            <a:r>
+              <a:rPr lang="en-US" sz="1400" dirty="0">
+                <a:solidFill>
+                  <a:schemeClr val="accent2"/>
+                </a:solidFill>
+              </a:rPr>
+              <a:t>Metrology 엔지니어</a:t>
+            </a:r>
+            <a:endParaRPr lang="en-US" sz="1400" dirty="0"/>
+          </a:p>
+        </p:txBody>
+      </p:sp>
+      <p:sp>
+        <p:nvSpPr>
+          <p:cNvPr id="34" name="row5-3"/>
+          <p:cNvSpPr txBox="1"/>
+          <p:nvPr/>
+        </p:nvSpPr>
+        <p:spPr>
+          <a:xfrm>
+            <a:off x="6263640" y="5788152"/>
+            <a:ext cx="5376672" cy="420624"/>
+          </a:xfrm>
+          <a:prstGeom prst="rect">
+            <a:avLst/>
+          </a:prstGeom>
+          <a:noFill/>
+          <a:ln/>
+        </p:spPr>
+        <p:txBody>
+          <a:bodyPr wrap="square" lIns="0" tIns="0" rIns="0" bIns="0" rtlCol="0" anchor="ctr"/>
+          <a:lstStyle/>
+          <a:p>
+            <a:pPr indent="0" marL="0">
+              <a:buNone/>
+            </a:pPr>
+            <a:r>
+              <a:rPr lang="en-US" sz="1400" dirty="0">
+                <a:solidFill>
+                  <a:schemeClr val="tx2"/>
+                </a:solidFill>
+              </a:rPr>
+              <a:t>별도 FTP 프로그램 없이 장비 파일을 웹에서 열람 · 다운로드</a:t>
+            </a:r>
+            <a:endParaRPr lang="en-US" sz="1400" dirty="0"/>
           </a:p>
         </p:txBody>
       </p:sp>
@@ -5148,7 +5296,7 @@
                   <a:schemeClr val="accent2"/>
                 </a:solidFill>
               </a:rPr>
-              <a:t>장비 상태 · 스토리지 용량 · H/W 관리</a:t>
+              <a:t>장비 상태 · 스토리지 · H/W 관리 · FTP 접속</a:t>
             </a:r>
             <a:endParaRPr lang="en-US" sz="1400" dirty="0"/>
           </a:p>
@@ -5184,7 +5332,7 @@
                   <a:schemeClr val="tx2"/>
                 </a:solidFill>
               </a:rPr>
-              <a:t>가용 장비, 디스크 용량, 하드웨어 지표</a:t>
+              <a:t>가용 장비, 디스크 용량, 하드웨어 지표, 장비 파일</a:t>
             </a:r>
             <a:endParaRPr lang="en-US" sz="1400" dirty="0"/>
           </a:p>
@@ -6250,7 +6398,7 @@
         </p:nvSpPr>
         <p:spPr>
           <a:xfrm>
-            <a:off x="731520" y="2057400"/>
+            <a:off x="731520" y="1828800"/>
             <a:ext cx="420624" cy="420624"/>
           </a:xfrm>
           <a:prstGeom prst="ellipse">
@@ -6288,7 +6436,7 @@
         </p:nvSpPr>
         <p:spPr>
           <a:xfrm>
-            <a:off x="1417320" y="2011680"/>
+            <a:off x="1417320" y="1783080"/>
             <a:ext cx="9966960" cy="502920"/>
           </a:xfrm>
           <a:prstGeom prst="rect">
@@ -6324,7 +6472,7 @@
         </p:nvSpPr>
         <p:spPr>
           <a:xfrm>
-            <a:off x="1417320" y="2606040"/>
+            <a:off x="1417320" y="2377440"/>
             <a:ext cx="9966960" cy="411480"/>
           </a:xfrm>
           <a:prstGeom prst="rect">
@@ -6360,7 +6508,7 @@
         </p:nvSpPr>
         <p:spPr>
           <a:xfrm>
-            <a:off x="731520" y="3520440"/>
+            <a:off x="731520" y="3108960"/>
             <a:ext cx="420624" cy="420624"/>
           </a:xfrm>
           <a:prstGeom prst="ellipse">
@@ -6398,7 +6546,7 @@
         </p:nvSpPr>
         <p:spPr>
           <a:xfrm>
-            <a:off x="1417320" y="3474720"/>
+            <a:off x="1417320" y="3063240"/>
             <a:ext cx="9966960" cy="502920"/>
           </a:xfrm>
           <a:prstGeom prst="rect">
@@ -6434,7 +6582,7 @@
         </p:nvSpPr>
         <p:spPr>
           <a:xfrm>
-            <a:off x="1417320" y="4069080"/>
+            <a:off x="1417320" y="3657600"/>
             <a:ext cx="9966960" cy="411480"/>
           </a:xfrm>
           <a:prstGeom prst="rect">
@@ -6456,7 +6604,7 @@
                   <a:schemeClr val="accent6"/>
                 </a:solidFill>
               </a:rPr>
-              <a:t>VeritySEM · Provision · Thickness 로 넓혀 Metrology Workspace 통합을 이어 갑니다.</a:t>
+              <a:t>VeritySEM · Provision · Thickness 로 넓혀 Metrology Workspace 통합을 이어 갑니다. VeritySEM · Provision 은 사전 조사를 시작했습니다.</a:t>
             </a:r>
             <a:endParaRPr lang="en-US" sz="1600" dirty="0"/>
           </a:p>
@@ -6495,6 +6643,1896 @@
               <a:t>일평균 접속자 60~70명 · 인라인 교대 구성원 · 공정/소자 엔지니어 · 검/계측 효율화 TF</a:t>
             </a:r>
             <a:endParaRPr lang="en-US" sz="1400" dirty="0"/>
+          </a:p>
+        </p:txBody>
+      </p:sp>
+      <p:sp>
+        <p:nvSpPr>
+          <p:cNvPr id="10" name="item3-0"/>
+          <p:cNvSpPr/>
+          <p:nvPr/>
+        </p:nvSpPr>
+        <p:spPr>
+          <a:xfrm>
+            <a:off x="731520" y="4389120"/>
+            <a:ext cx="420624" cy="420624"/>
+          </a:xfrm>
+          <a:prstGeom prst="ellipse">
+            <a:avLst/>
+          </a:prstGeom>
+          <a:solidFill>
+            <a:schemeClr val="accent1"/>
+          </a:solidFill>
+          <a:ln/>
+        </p:spPr>
+        <p:txBody>
+          <a:bodyPr wrap="square" lIns="0" tIns="0" rIns="0" bIns="0" rtlCol="0" anchor="ctr"/>
+          <a:lstStyle/>
+          <a:p>
+            <a:pPr algn="ctr" indent="0" marL="0">
+              <a:buNone/>
+            </a:pPr>
+            <a:r>
+              <a:rPr lang="en-US" sz="1400" b="1" dirty="0">
+                <a:solidFill>
+                  <a:schemeClr val="bg1"/>
+                </a:solidFill>
+              </a:rPr>
+              <a:t>3</a:t>
+            </a:r>
+            <a:endParaRPr lang="en-US" sz="1400" dirty="0"/>
+          </a:p>
+        </p:txBody>
+      </p:sp>
+      <p:sp>
+        <p:nvSpPr>
+          <p:cNvPr id="11" name="item3-1"/>
+          <p:cNvSpPr txBox="1"/>
+          <p:nvPr/>
+        </p:nvSpPr>
+        <p:spPr>
+          <a:xfrm>
+            <a:off x="1417320" y="4343400"/>
+            <a:ext cx="9966960" cy="502920"/>
+          </a:xfrm>
+          <a:prstGeom prst="rect">
+            <a:avLst/>
+          </a:prstGeom>
+          <a:noFill/>
+          <a:ln/>
+        </p:spPr>
+        <p:txBody>
+          <a:bodyPr wrap="square" lIns="0" tIns="0" rIns="0" bIns="0" rtlCol="0" anchor="ctr"/>
+          <a:lstStyle/>
+          <a:p>
+            <a:pPr indent="0" marL="0">
+              <a:buNone/>
+            </a:pPr>
+            <a:r>
+              <a:rPr lang="en-US" sz="2600" b="1" dirty="0">
+                <a:solidFill>
+                  <a:schemeClr val="bg1"/>
+                </a:solidFill>
+              </a:rPr>
+              <a:t>Recipe 일괄 복사 도구</a:t>
+            </a:r>
+            <a:endParaRPr lang="en-US" sz="2600" dirty="0"/>
+          </a:p>
+        </p:txBody>
+      </p:sp>
+      <p:sp>
+        <p:nvSpPr>
+          <p:cNvPr id="12" name="item3-2"/>
+          <p:cNvSpPr txBox="1"/>
+          <p:nvPr/>
+        </p:nvSpPr>
+        <p:spPr>
+          <a:xfrm>
+            <a:off x="1417320" y="4937760"/>
+            <a:ext cx="9966960" cy="411480"/>
+          </a:xfrm>
+          <a:prstGeom prst="rect">
+            <a:avLst/>
+          </a:prstGeom>
+          <a:noFill/>
+          <a:ln/>
+        </p:spPr>
+        <p:txBody>
+          <a:bodyPr wrap="square" lIns="0" tIns="0" rIns="0" bIns="0" rtlCol="0" anchor="t"/>
+          <a:lstStyle/>
+          <a:p>
+            <a:pPr indent="0" marL="0">
+              <a:buNone/>
+            </a:pPr>
+            <a:r>
+              <a:rPr lang="en-US" sz="1600" dirty="0">
+                <a:solidFill>
+                  <a:schemeClr val="accent6"/>
+                </a:solidFill>
+              </a:rPr>
+              <a:t>여러 장비에 Recipe 를 한 번에 복사하는 별도 앱을 설계하고 있습니다.</a:t>
+            </a:r>
+            <a:endParaRPr lang="en-US" sz="1600" dirty="0"/>
+          </a:p>
+        </p:txBody>
+      </p:sp>
+    </p:spTree>
+  </p:cSld>
+  <p:clrMapOvr>
+    <a:masterClrMapping/>
+  </p:clrMapOvr>
+</p:sld>
+</file>
+
+<file path=ppt/slides/slide8.xml><?xml version="1.0" encoding="utf-8"?>
+<p:sld xmlns:a="http://schemas.openxmlformats.org/drawingml/2006/main" xmlns:r="http://schemas.openxmlformats.org/officeDocument/2006/relationships" xmlns:p="http://schemas.openxmlformats.org/presentationml/2006/main">
+  <p:cSld name="Slide 6">
+    <p:spTree>
+      <p:nvGrpSpPr>
+        <p:cNvPr id="1" name=""/>
+        <p:cNvGrpSpPr/>
+        <p:nvPr/>
+      </p:nvGrpSpPr>
+      <p:grpSpPr>
+        <a:xfrm>
+          <a:off x="0" y="0"/>
+          <a:ext cx="0" cy="0"/>
+          <a:chOff x="0" y="0"/>
+          <a:chExt cx="0" cy="0"/>
+        </a:xfrm>
+      </p:grpSpPr>
+      <p:sp>
+        <p:nvSpPr>
+          <p:cNvPr id="2" name="Text 0"/>
+          <p:cNvSpPr/>
+          <p:nvPr>
+            <p:ph idx="100" type="title" hasCustomPrompt="1"/>
+          </p:nvPr>
+        </p:nvSpPr>
+        <p:spPr>
+          <a:xfrm>
+            <a:off x="548640" y="411480"/>
+            <a:ext cx="11091672" cy="868680"/>
+          </a:xfrm>
+          <a:prstGeom prst="rect">
+            <a:avLst/>
+          </a:prstGeom>
+          <a:noFill/>
+          <a:ln/>
+        </p:spPr>
+        <p:txBody>
+          <a:bodyPr wrap="square" lIns="0" tIns="0" rIns="0" bIns="0" rtlCol="0" anchor="ctr"/>
+          <a:lstStyle/>
+          <a:p>
+            <a:pPr algn="l" indent="0" marL="0">
+              <a:buNone/>
+            </a:pPr>
+            <a:r>
+              <a:rPr lang="en-US" sz="3600" b="1" dirty="0">
+                <a:solidFill>
+                  <a:schemeClr val="tx1"/>
+                </a:solidFill>
+              </a:rPr>
+              <a:t>장비 파일을 FTP 프로그램 없이 엽니다</a:t>
+            </a:r>
+            <a:endParaRPr lang="en-US" sz="3600" dirty="0"/>
+          </a:p>
+        </p:txBody>
+      </p:sp>
+      <p:sp>
+        <p:nvSpPr>
+          <p:cNvPr id="3" name="text-80"/>
+          <p:cNvSpPr txBox="1"/>
+          <p:nvPr/>
+        </p:nvSpPr>
+        <p:spPr>
+          <a:xfrm>
+            <a:off x="548640" y="1508760"/>
+            <a:ext cx="4846320" cy="1463040"/>
+          </a:xfrm>
+          <a:prstGeom prst="rect">
+            <a:avLst/>
+          </a:prstGeom>
+          <a:noFill/>
+          <a:ln/>
+        </p:spPr>
+        <p:txBody>
+          <a:bodyPr wrap="square" lIns="0" tIns="0" rIns="0" bIns="0" rtlCol="0" anchor="t"/>
+          <a:lstStyle/>
+          <a:p>
+            <a:pPr indent="0" marL="0">
+              <a:buNone/>
+            </a:pPr>
+            <a:r>
+              <a:rPr lang="en-US" sz="1500" dirty="0">
+                <a:solidFill>
+                  <a:schemeClr val="tx2"/>
+                </a:solidFill>
+              </a:rPr>
+              <a:t>2026-10-20 에 장비 상태 아래 FTP 접속 탭을 열었습니다. CD-SEM · HV-SEM 장비를 고르면 장비의 폴더와 파일을 스큐노노에서 바로 엽니다.</a:t>
+            </a:r>
+            <a:endParaRPr lang="en-US" sz="1500" dirty="0"/>
+          </a:p>
+        </p:txBody>
+      </p:sp>
+      <p:sp>
+        <p:nvSpPr>
+          <p:cNvPr id="4" name="text-81"/>
+          <p:cNvSpPr txBox="1"/>
+          <p:nvPr/>
+        </p:nvSpPr>
+        <p:spPr>
+          <a:xfrm>
+            <a:off x="548640" y="3154680"/>
+            <a:ext cx="4846320" cy="365760"/>
+          </a:xfrm>
+          <a:prstGeom prst="rect">
+            <a:avLst/>
+          </a:prstGeom>
+          <a:noFill/>
+          <a:ln/>
+        </p:spPr>
+        <p:txBody>
+          <a:bodyPr wrap="square" lIns="0" tIns="0" rIns="0" bIns="0" rtlCol="0" anchor="t"/>
+          <a:lstStyle/>
+          <a:p>
+            <a:pPr indent="0" marL="0">
+              <a:buNone/>
+            </a:pPr>
+            <a:r>
+              <a:rPr lang="en-US" sz="1600" b="1" dirty="0">
+                <a:solidFill>
+                  <a:schemeClr val="tx1"/>
+                </a:solidFill>
+              </a:rPr>
+              <a:t>대상 팀 5곳 · Metrology 엔지니어</a:t>
+            </a:r>
+            <a:endParaRPr lang="en-US" sz="1600" dirty="0"/>
+          </a:p>
+        </p:txBody>
+      </p:sp>
+      <p:sp>
+        <p:nvSpPr>
+          <p:cNvPr id="5" name="card-82"/>
+          <p:cNvSpPr/>
+          <p:nvPr/>
+        </p:nvSpPr>
+        <p:spPr>
+          <a:xfrm>
+            <a:off x="548640" y="3657600"/>
+            <a:ext cx="4846320" cy="658368"/>
+          </a:xfrm>
+          <a:prstGeom prst="roundRect">
+            <a:avLst>
+              <a:gd name="adj" fmla="val 16667"/>
+            </a:avLst>
+          </a:prstGeom>
+          <a:solidFill>
+            <a:schemeClr val="bg2"/>
+          </a:solidFill>
+          <a:ln w="12700">
+            <a:solidFill>
+              <a:schemeClr val="bg2"/>
+            </a:solidFill>
+            <a:prstDash val="solid"/>
+          </a:ln>
+        </p:spPr>
+      </p:sp>
+      <p:sp>
+        <p:nvSpPr>
+          <p:cNvPr id="6" name="text-83"/>
+          <p:cNvSpPr txBox="1"/>
+          <p:nvPr/>
+        </p:nvSpPr>
+        <p:spPr>
+          <a:xfrm>
+            <a:off x="822960" y="3657600"/>
+            <a:ext cx="3657600" cy="658368"/>
+          </a:xfrm>
+          <a:prstGeom prst="rect">
+            <a:avLst/>
+          </a:prstGeom>
+          <a:noFill/>
+          <a:ln/>
+        </p:spPr>
+        <p:txBody>
+          <a:bodyPr wrap="square" lIns="0" tIns="0" rIns="0" bIns="0" rtlCol="0" anchor="ctr"/>
+          <a:lstStyle/>
+          <a:p>
+            <a:pPr indent="0" marL="0">
+              <a:buNone/>
+            </a:pPr>
+            <a:r>
+              <a:rPr lang="en-US" sz="1800" b="1" dirty="0">
+                <a:solidFill>
+                  <a:schemeClr val="tx1"/>
+                </a:solidFill>
+              </a:rPr>
+              <a:t>DRAM · NAND MI개발</a:t>
+            </a:r>
+            <a:endParaRPr lang="en-US" sz="1800" dirty="0"/>
+          </a:p>
+        </p:txBody>
+      </p:sp>
+      <p:sp>
+        <p:nvSpPr>
+          <p:cNvPr id="7" name="text-84"/>
+          <p:cNvSpPr txBox="1"/>
+          <p:nvPr/>
+        </p:nvSpPr>
+        <p:spPr>
+          <a:xfrm>
+            <a:off x="4480560" y="3657600"/>
+            <a:ext cx="640080" cy="658368"/>
+          </a:xfrm>
+          <a:prstGeom prst="rect">
+            <a:avLst/>
+          </a:prstGeom>
+          <a:noFill/>
+          <a:ln/>
+        </p:spPr>
+        <p:txBody>
+          <a:bodyPr wrap="square" lIns="0" tIns="0" rIns="0" bIns="0" rtlCol="0" anchor="ctr"/>
+          <a:lstStyle/>
+          <a:p>
+            <a:pPr algn="r" indent="0" marL="0">
+              <a:buNone/>
+            </a:pPr>
+            <a:r>
+              <a:rPr lang="en-US" sz="1600" b="1" dirty="0">
+                <a:solidFill>
+                  <a:schemeClr val="accent1"/>
+                </a:solidFill>
+              </a:rPr>
+              <a:t>2팀</a:t>
+            </a:r>
+            <a:endParaRPr lang="en-US" sz="1600" dirty="0"/>
+          </a:p>
+        </p:txBody>
+      </p:sp>
+      <p:sp>
+        <p:nvSpPr>
+          <p:cNvPr id="8" name="card-85"/>
+          <p:cNvSpPr/>
+          <p:nvPr/>
+        </p:nvSpPr>
+        <p:spPr>
+          <a:xfrm>
+            <a:off x="548640" y="4480560"/>
+            <a:ext cx="4846320" cy="658368"/>
+          </a:xfrm>
+          <a:prstGeom prst="roundRect">
+            <a:avLst>
+              <a:gd name="adj" fmla="val 16667"/>
+            </a:avLst>
+          </a:prstGeom>
+          <a:solidFill>
+            <a:schemeClr val="bg2"/>
+          </a:solidFill>
+          <a:ln w="12700">
+            <a:solidFill>
+              <a:schemeClr val="bg2"/>
+            </a:solidFill>
+            <a:prstDash val="solid"/>
+          </a:ln>
+        </p:spPr>
+      </p:sp>
+      <p:sp>
+        <p:nvSpPr>
+          <p:cNvPr id="9" name="text-86"/>
+          <p:cNvSpPr txBox="1"/>
+          <p:nvPr/>
+        </p:nvSpPr>
+        <p:spPr>
+          <a:xfrm>
+            <a:off x="822960" y="4480560"/>
+            <a:ext cx="3657600" cy="658368"/>
+          </a:xfrm>
+          <a:prstGeom prst="rect">
+            <a:avLst/>
+          </a:prstGeom>
+          <a:noFill/>
+          <a:ln/>
+        </p:spPr>
+        <p:txBody>
+          <a:bodyPr wrap="square" lIns="0" tIns="0" rIns="0" bIns="0" rtlCol="0" anchor="ctr"/>
+          <a:lstStyle/>
+          <a:p>
+            <a:pPr indent="0" marL="0">
+              <a:buNone/>
+            </a:pPr>
+            <a:r>
+              <a:rPr lang="en-US" sz="1800" b="1" dirty="0">
+                <a:solidFill>
+                  <a:schemeClr val="tx1"/>
+                </a:solidFill>
+              </a:rPr>
+              <a:t>DRAM · NAND Metrology기술</a:t>
+            </a:r>
+            <a:endParaRPr lang="en-US" sz="1800" dirty="0"/>
+          </a:p>
+        </p:txBody>
+      </p:sp>
+      <p:sp>
+        <p:nvSpPr>
+          <p:cNvPr id="10" name="text-87"/>
+          <p:cNvSpPr txBox="1"/>
+          <p:nvPr/>
+        </p:nvSpPr>
+        <p:spPr>
+          <a:xfrm>
+            <a:off x="4480560" y="4480560"/>
+            <a:ext cx="640080" cy="658368"/>
+          </a:xfrm>
+          <a:prstGeom prst="rect">
+            <a:avLst/>
+          </a:prstGeom>
+          <a:noFill/>
+          <a:ln/>
+        </p:spPr>
+        <p:txBody>
+          <a:bodyPr wrap="square" lIns="0" tIns="0" rIns="0" bIns="0" rtlCol="0" anchor="ctr"/>
+          <a:lstStyle/>
+          <a:p>
+            <a:pPr algn="r" indent="0" marL="0">
+              <a:buNone/>
+            </a:pPr>
+            <a:r>
+              <a:rPr lang="en-US" sz="1600" b="1" dirty="0">
+                <a:solidFill>
+                  <a:schemeClr val="accent1"/>
+                </a:solidFill>
+              </a:rPr>
+              <a:t>2팀</a:t>
+            </a:r>
+            <a:endParaRPr lang="en-US" sz="1600" dirty="0"/>
+          </a:p>
+        </p:txBody>
+      </p:sp>
+      <p:sp>
+        <p:nvSpPr>
+          <p:cNvPr id="11" name="card-88"/>
+          <p:cNvSpPr/>
+          <p:nvPr/>
+        </p:nvSpPr>
+        <p:spPr>
+          <a:xfrm>
+            <a:off x="548640" y="5303520"/>
+            <a:ext cx="4846320" cy="658368"/>
+          </a:xfrm>
+          <a:prstGeom prst="roundRect">
+            <a:avLst>
+              <a:gd name="adj" fmla="val 16667"/>
+            </a:avLst>
+          </a:prstGeom>
+          <a:solidFill>
+            <a:schemeClr val="bg2"/>
+          </a:solidFill>
+          <a:ln w="12700">
+            <a:solidFill>
+              <a:schemeClr val="bg2"/>
+            </a:solidFill>
+            <a:prstDash val="solid"/>
+          </a:ln>
+        </p:spPr>
+      </p:sp>
+      <p:sp>
+        <p:nvSpPr>
+          <p:cNvPr id="12" name="text-89"/>
+          <p:cNvSpPr txBox="1"/>
+          <p:nvPr/>
+        </p:nvSpPr>
+        <p:spPr>
+          <a:xfrm>
+            <a:off x="822960" y="5303520"/>
+            <a:ext cx="3657600" cy="658368"/>
+          </a:xfrm>
+          <a:prstGeom prst="rect">
+            <a:avLst/>
+          </a:prstGeom>
+          <a:noFill/>
+          <a:ln/>
+        </p:spPr>
+        <p:txBody>
+          <a:bodyPr wrap="square" lIns="0" tIns="0" rIns="0" bIns="0" rtlCol="0" anchor="ctr"/>
+          <a:lstStyle/>
+          <a:p>
+            <a:pPr indent="0" marL="0">
+              <a:buNone/>
+            </a:pPr>
+            <a:r>
+              <a:rPr lang="en-US" sz="1800" b="1" dirty="0">
+                <a:solidFill>
+                  <a:schemeClr val="tx1"/>
+                </a:solidFill>
+              </a:rPr>
+              <a:t>기반기술전략</a:t>
+            </a:r>
+            <a:endParaRPr lang="en-US" sz="1800" dirty="0"/>
+          </a:p>
+        </p:txBody>
+      </p:sp>
+      <p:sp>
+        <p:nvSpPr>
+          <p:cNvPr id="13" name="text-90"/>
+          <p:cNvSpPr txBox="1"/>
+          <p:nvPr/>
+        </p:nvSpPr>
+        <p:spPr>
+          <a:xfrm>
+            <a:off x="4480560" y="5303520"/>
+            <a:ext cx="640080" cy="658368"/>
+          </a:xfrm>
+          <a:prstGeom prst="rect">
+            <a:avLst/>
+          </a:prstGeom>
+          <a:noFill/>
+          <a:ln/>
+        </p:spPr>
+        <p:txBody>
+          <a:bodyPr wrap="square" lIns="0" tIns="0" rIns="0" bIns="0" rtlCol="0" anchor="ctr"/>
+          <a:lstStyle/>
+          <a:p>
+            <a:pPr algn="r" indent="0" marL="0">
+              <a:buNone/>
+            </a:pPr>
+            <a:r>
+              <a:rPr lang="en-US" sz="1600" b="1" dirty="0">
+                <a:solidFill>
+                  <a:schemeClr val="accent1"/>
+                </a:solidFill>
+              </a:rPr>
+              <a:t>1팀</a:t>
+            </a:r>
+            <a:endParaRPr lang="en-US" sz="1600" dirty="0"/>
+          </a:p>
+        </p:txBody>
+      </p:sp>
+      <p:sp>
+        <p:nvSpPr>
+          <p:cNvPr id="14" name="card-91"/>
+          <p:cNvSpPr/>
+          <p:nvPr/>
+        </p:nvSpPr>
+        <p:spPr>
+          <a:xfrm>
+            <a:off x="5852160" y="1463040"/>
+            <a:ext cx="5788152" cy="4663440"/>
+          </a:xfrm>
+          <a:prstGeom prst="roundRect">
+            <a:avLst>
+              <a:gd name="adj" fmla="val 2353"/>
+            </a:avLst>
+          </a:prstGeom>
+          <a:solidFill>
+            <a:srgbClr val="15110D"/>
+          </a:solidFill>
+          <a:ln w="12700">
+            <a:solidFill>
+              <a:srgbClr val="15110D"/>
+            </a:solidFill>
+            <a:prstDash val="solid"/>
+          </a:ln>
+        </p:spPr>
+      </p:sp>
+      <p:sp>
+        <p:nvSpPr>
+          <p:cNvPr id="15" name="dot-92"/>
+          <p:cNvSpPr/>
+          <p:nvPr/>
+        </p:nvSpPr>
+        <p:spPr>
+          <a:xfrm>
+            <a:off x="6217920" y="1828800"/>
+            <a:ext cx="420624" cy="420624"/>
+          </a:xfrm>
+          <a:prstGeom prst="ellipse">
+            <a:avLst/>
+          </a:prstGeom>
+          <a:solidFill>
+            <a:schemeClr val="accent1"/>
+          </a:solidFill>
+          <a:ln/>
+        </p:spPr>
+        <p:txBody>
+          <a:bodyPr wrap="square" lIns="0" tIns="0" rIns="0" bIns="0" rtlCol="0" anchor="ctr"/>
+          <a:lstStyle/>
+          <a:p>
+            <a:pPr algn="ctr" indent="0" marL="0">
+              <a:buNone/>
+            </a:pPr>
+            <a:r>
+              <a:rPr lang="en-US" sz="1400" b="1" dirty="0">
+                <a:solidFill>
+                  <a:schemeClr val="bg1"/>
+                </a:solidFill>
+              </a:rPr>
+              <a:t>1</a:t>
+            </a:r>
+            <a:endParaRPr lang="en-US" sz="1400" dirty="0"/>
+          </a:p>
+        </p:txBody>
+      </p:sp>
+      <p:sp>
+        <p:nvSpPr>
+          <p:cNvPr id="16" name="text-93"/>
+          <p:cNvSpPr txBox="1"/>
+          <p:nvPr/>
+        </p:nvSpPr>
+        <p:spPr>
+          <a:xfrm>
+            <a:off x="6858000" y="1810512"/>
+            <a:ext cx="4480560" cy="365760"/>
+          </a:xfrm>
+          <a:prstGeom prst="rect">
+            <a:avLst/>
+          </a:prstGeom>
+          <a:noFill/>
+          <a:ln/>
+        </p:spPr>
+        <p:txBody>
+          <a:bodyPr wrap="square" lIns="0" tIns="0" rIns="0" bIns="0" rtlCol="0" anchor="t"/>
+          <a:lstStyle/>
+          <a:p>
+            <a:pPr indent="0" marL="0">
+              <a:buNone/>
+            </a:pPr>
+            <a:r>
+              <a:rPr lang="en-US" sz="1800" b="1" dirty="0">
+                <a:solidFill>
+                  <a:schemeClr val="bg1"/>
+                </a:solidFill>
+              </a:rPr>
+              <a:t>탐색</a:t>
+            </a:r>
+            <a:endParaRPr lang="en-US" sz="1800" dirty="0"/>
+          </a:p>
+        </p:txBody>
+      </p:sp>
+      <p:sp>
+        <p:nvSpPr>
+          <p:cNvPr id="17" name="text-94"/>
+          <p:cNvSpPr txBox="1"/>
+          <p:nvPr/>
+        </p:nvSpPr>
+        <p:spPr>
+          <a:xfrm>
+            <a:off x="6858000" y="2212848"/>
+            <a:ext cx="4480560" cy="365760"/>
+          </a:xfrm>
+          <a:prstGeom prst="rect">
+            <a:avLst/>
+          </a:prstGeom>
+          <a:noFill/>
+          <a:ln/>
+        </p:spPr>
+        <p:txBody>
+          <a:bodyPr wrap="square" lIns="0" tIns="0" rIns="0" bIns="0" rtlCol="0" anchor="t"/>
+          <a:lstStyle/>
+          <a:p>
+            <a:pPr indent="0" marL="0">
+              <a:buNone/>
+            </a:pPr>
+            <a:r>
+              <a:rPr lang="en-US" sz="1400" dirty="0">
+                <a:solidFill>
+                  <a:schemeClr val="accent6"/>
+                </a:solidFill>
+              </a:rPr>
+              <a:t>폴더를 눌러 이동하거나 경로를 직접 입력</a:t>
+            </a:r>
+            <a:endParaRPr lang="en-US" sz="1400" dirty="0"/>
+          </a:p>
+        </p:txBody>
+      </p:sp>
+      <p:sp>
+        <p:nvSpPr>
+          <p:cNvPr id="18" name="dot-95"/>
+          <p:cNvSpPr/>
+          <p:nvPr/>
+        </p:nvSpPr>
+        <p:spPr>
+          <a:xfrm>
+            <a:off x="6217920" y="2880360"/>
+            <a:ext cx="420624" cy="420624"/>
+          </a:xfrm>
+          <a:prstGeom prst="ellipse">
+            <a:avLst/>
+          </a:prstGeom>
+          <a:solidFill>
+            <a:schemeClr val="accent1"/>
+          </a:solidFill>
+          <a:ln/>
+        </p:spPr>
+        <p:txBody>
+          <a:bodyPr wrap="square" lIns="0" tIns="0" rIns="0" bIns="0" rtlCol="0" anchor="ctr"/>
+          <a:lstStyle/>
+          <a:p>
+            <a:pPr algn="ctr" indent="0" marL="0">
+              <a:buNone/>
+            </a:pPr>
+            <a:r>
+              <a:rPr lang="en-US" sz="1400" b="1" dirty="0">
+                <a:solidFill>
+                  <a:schemeClr val="bg1"/>
+                </a:solidFill>
+              </a:rPr>
+              <a:t>2</a:t>
+            </a:r>
+            <a:endParaRPr lang="en-US" sz="1400" dirty="0"/>
+          </a:p>
+        </p:txBody>
+      </p:sp>
+      <p:sp>
+        <p:nvSpPr>
+          <p:cNvPr id="19" name="text-96"/>
+          <p:cNvSpPr txBox="1"/>
+          <p:nvPr/>
+        </p:nvSpPr>
+        <p:spPr>
+          <a:xfrm>
+            <a:off x="6858000" y="2862072"/>
+            <a:ext cx="4480560" cy="365760"/>
+          </a:xfrm>
+          <a:prstGeom prst="rect">
+            <a:avLst/>
+          </a:prstGeom>
+          <a:noFill/>
+          <a:ln/>
+        </p:spPr>
+        <p:txBody>
+          <a:bodyPr wrap="square" lIns="0" tIns="0" rIns="0" bIns="0" rtlCol="0" anchor="t"/>
+          <a:lstStyle/>
+          <a:p>
+            <a:pPr indent="0" marL="0">
+              <a:buNone/>
+            </a:pPr>
+            <a:r>
+              <a:rPr lang="en-US" sz="1800" b="1" dirty="0">
+                <a:solidFill>
+                  <a:schemeClr val="bg1"/>
+                </a:solidFill>
+              </a:rPr>
+              <a:t>다운로드</a:t>
+            </a:r>
+            <a:endParaRPr lang="en-US" sz="1800" dirty="0"/>
+          </a:p>
+        </p:txBody>
+      </p:sp>
+      <p:sp>
+        <p:nvSpPr>
+          <p:cNvPr id="20" name="text-97"/>
+          <p:cNvSpPr txBox="1"/>
+          <p:nvPr/>
+        </p:nvSpPr>
+        <p:spPr>
+          <a:xfrm>
+            <a:off x="6858000" y="3264408"/>
+            <a:ext cx="4480560" cy="365760"/>
+          </a:xfrm>
+          <a:prstGeom prst="rect">
+            <a:avLst/>
+          </a:prstGeom>
+          <a:noFill/>
+          <a:ln/>
+        </p:spPr>
+        <p:txBody>
+          <a:bodyPr wrap="square" lIns="0" tIns="0" rIns="0" bIns="0" rtlCol="0" anchor="t"/>
+          <a:lstStyle/>
+          <a:p>
+            <a:pPr indent="0" marL="0">
+              <a:buNone/>
+            </a:pPr>
+            <a:r>
+              <a:rPr lang="en-US" sz="1400" dirty="0">
+                <a:solidFill>
+                  <a:schemeClr val="accent6"/>
+                </a:solidFill>
+              </a:rPr>
+              <a:t>파일 하나씩, 여러 개는 zip 한 개로</a:t>
+            </a:r>
+            <a:endParaRPr lang="en-US" sz="1400" dirty="0"/>
+          </a:p>
+        </p:txBody>
+      </p:sp>
+      <p:sp>
+        <p:nvSpPr>
+          <p:cNvPr id="21" name="dot-98"/>
+          <p:cNvSpPr/>
+          <p:nvPr/>
+        </p:nvSpPr>
+        <p:spPr>
+          <a:xfrm>
+            <a:off x="6217920" y="3931920"/>
+            <a:ext cx="420624" cy="420624"/>
+          </a:xfrm>
+          <a:prstGeom prst="ellipse">
+            <a:avLst/>
+          </a:prstGeom>
+          <a:solidFill>
+            <a:schemeClr val="accent1"/>
+          </a:solidFill>
+          <a:ln/>
+        </p:spPr>
+        <p:txBody>
+          <a:bodyPr wrap="square" lIns="0" tIns="0" rIns="0" bIns="0" rtlCol="0" anchor="ctr"/>
+          <a:lstStyle/>
+          <a:p>
+            <a:pPr algn="ctr" indent="0" marL="0">
+              <a:buNone/>
+            </a:pPr>
+            <a:r>
+              <a:rPr lang="en-US" sz="1400" b="1" dirty="0">
+                <a:solidFill>
+                  <a:schemeClr val="bg1"/>
+                </a:solidFill>
+              </a:rPr>
+              <a:t>3</a:t>
+            </a:r>
+            <a:endParaRPr lang="en-US" sz="1400" dirty="0"/>
+          </a:p>
+        </p:txBody>
+      </p:sp>
+      <p:sp>
+        <p:nvSpPr>
+          <p:cNvPr id="22" name="text-99"/>
+          <p:cNvSpPr txBox="1"/>
+          <p:nvPr/>
+        </p:nvSpPr>
+        <p:spPr>
+          <a:xfrm>
+            <a:off x="6858000" y="3913632"/>
+            <a:ext cx="4480560" cy="365760"/>
+          </a:xfrm>
+          <a:prstGeom prst="rect">
+            <a:avLst/>
+          </a:prstGeom>
+          <a:noFill/>
+          <a:ln/>
+        </p:spPr>
+        <p:txBody>
+          <a:bodyPr wrap="square" lIns="0" tIns="0" rIns="0" bIns="0" rtlCol="0" anchor="t"/>
+          <a:lstStyle/>
+          <a:p>
+            <a:pPr indent="0" marL="0">
+              <a:buNone/>
+            </a:pPr>
+            <a:r>
+              <a:rPr lang="en-US" sz="1800" b="1" dirty="0">
+                <a:solidFill>
+                  <a:schemeClr val="bg1"/>
+                </a:solidFill>
+              </a:rPr>
+              <a:t>링크 공유</a:t>
+            </a:r>
+            <a:endParaRPr lang="en-US" sz="1800" dirty="0"/>
+          </a:p>
+        </p:txBody>
+      </p:sp>
+      <p:sp>
+        <p:nvSpPr>
+          <p:cNvPr id="23" name="text-100"/>
+          <p:cNvSpPr txBox="1"/>
+          <p:nvPr/>
+        </p:nvSpPr>
+        <p:spPr>
+          <a:xfrm>
+            <a:off x="6858000" y="4315968"/>
+            <a:ext cx="4480560" cy="365760"/>
+          </a:xfrm>
+          <a:prstGeom prst="rect">
+            <a:avLst/>
+          </a:prstGeom>
+          <a:noFill/>
+          <a:ln/>
+        </p:spPr>
+        <p:txBody>
+          <a:bodyPr wrap="square" lIns="0" tIns="0" rIns="0" bIns="0" rtlCol="0" anchor="t"/>
+          <a:lstStyle/>
+          <a:p>
+            <a:pPr indent="0" marL="0">
+              <a:buNone/>
+            </a:pPr>
+            <a:r>
+              <a:rPr lang="en-US" sz="1400" dirty="0">
+                <a:solidFill>
+                  <a:schemeClr val="accent6"/>
+                </a:solidFill>
+              </a:rPr>
+              <a:t>주소에 장비와 경로가 담겨 그대로 공유</a:t>
+            </a:r>
+            <a:endParaRPr lang="en-US" sz="1400" dirty="0"/>
+          </a:p>
+        </p:txBody>
+      </p:sp>
+      <p:sp>
+        <p:nvSpPr>
+          <p:cNvPr id="24" name="dot-101"/>
+          <p:cNvSpPr/>
+          <p:nvPr/>
+        </p:nvSpPr>
+        <p:spPr>
+          <a:xfrm>
+            <a:off x="6217920" y="4983480"/>
+            <a:ext cx="420624" cy="420624"/>
+          </a:xfrm>
+          <a:prstGeom prst="ellipse">
+            <a:avLst/>
+          </a:prstGeom>
+          <a:solidFill>
+            <a:schemeClr val="accent1"/>
+          </a:solidFill>
+          <a:ln/>
+        </p:spPr>
+        <p:txBody>
+          <a:bodyPr wrap="square" lIns="0" tIns="0" rIns="0" bIns="0" rtlCol="0" anchor="ctr"/>
+          <a:lstStyle/>
+          <a:p>
+            <a:pPr algn="ctr" indent="0" marL="0">
+              <a:buNone/>
+            </a:pPr>
+            <a:r>
+              <a:rPr lang="en-US" sz="1400" b="1" dirty="0">
+                <a:solidFill>
+                  <a:schemeClr val="bg1"/>
+                </a:solidFill>
+              </a:rPr>
+              <a:t>4</a:t>
+            </a:r>
+            <a:endParaRPr lang="en-US" sz="1400" dirty="0"/>
+          </a:p>
+        </p:txBody>
+      </p:sp>
+      <p:sp>
+        <p:nvSpPr>
+          <p:cNvPr id="25" name="text-102"/>
+          <p:cNvSpPr txBox="1"/>
+          <p:nvPr/>
+        </p:nvSpPr>
+        <p:spPr>
+          <a:xfrm>
+            <a:off x="6858000" y="4965192"/>
+            <a:ext cx="4480560" cy="365760"/>
+          </a:xfrm>
+          <a:prstGeom prst="rect">
+            <a:avLst/>
+          </a:prstGeom>
+          <a:noFill/>
+          <a:ln/>
+        </p:spPr>
+        <p:txBody>
+          <a:bodyPr wrap="square" lIns="0" tIns="0" rIns="0" bIns="0" rtlCol="0" anchor="t"/>
+          <a:lstStyle/>
+          <a:p>
+            <a:pPr indent="0" marL="0">
+              <a:buNone/>
+            </a:pPr>
+            <a:r>
+              <a:rPr lang="en-US" sz="1800" b="1" dirty="0">
+                <a:solidFill>
+                  <a:schemeClr val="bg1"/>
+                </a:solidFill>
+              </a:rPr>
+              <a:t>안정성</a:t>
+            </a:r>
+            <a:endParaRPr lang="en-US" sz="1800" dirty="0"/>
+          </a:p>
+        </p:txBody>
+      </p:sp>
+      <p:sp>
+        <p:nvSpPr>
+          <p:cNvPr id="26" name="text-103"/>
+          <p:cNvSpPr txBox="1"/>
+          <p:nvPr/>
+        </p:nvSpPr>
+        <p:spPr>
+          <a:xfrm>
+            <a:off x="6858000" y="5367528"/>
+            <a:ext cx="4480560" cy="365760"/>
+          </a:xfrm>
+          <a:prstGeom prst="rect">
+            <a:avLst/>
+          </a:prstGeom>
+          <a:noFill/>
+          <a:ln/>
+        </p:spPr>
+        <p:txBody>
+          <a:bodyPr wrap="square" lIns="0" tIns="0" rIns="0" bIns="0" rtlCol="0" anchor="t"/>
+          <a:lstStyle/>
+          <a:p>
+            <a:pPr indent="0" marL="0">
+              <a:buNone/>
+            </a:pPr>
+            <a:r>
+              <a:rPr lang="en-US" sz="1400" dirty="0">
+                <a:solidFill>
+                  <a:schemeClr val="accent6"/>
+                </a:solidFill>
+              </a:rPr>
+              <a:t>동시 다운로드 · FTP 세션 수 제한</a:t>
+            </a:r>
+            <a:endParaRPr lang="en-US" sz="1400" dirty="0"/>
+          </a:p>
+        </p:txBody>
+      </p:sp>
+      <p:sp>
+        <p:nvSpPr>
+          <p:cNvPr id="25" name="Slide Number Placeholder 0"/>
+          <p:cNvSpPr>
+            <a:spLocks noGrp="1"/>
+          </p:cNvSpPr>
+          <p:nvPr>
+            <p:ph type="sldNum" sz="quarter" idx="4294967295"/>
+          </p:nvPr>
+        </p:nvSpPr>
+        <p:spPr>
+          <a:xfrm>
+            <a:off x="11091672" y="6400800"/>
+            <a:ext cx="548640" cy="274320"/>
+          </a:xfrm>
+          <a:prstGeom prst="rect">
+            <a:avLst/>
+          </a:prstGeom>
+          <a:extLst>
+            <a:ext uri="{C572A759-6A51-4108-AA02-DFA0A04FC94B}">
+              <ma14:wrappingTextBoxFlag xmlns:ma14="http://schemas.microsoft.com/office/mac/drawingml/2011/main" val="0"/>
+            </a:ext>
+          </a:extLst>
+        </p:spPr>
+        <p:txBody>
+          <a:bodyPr/>
+          <a:lstStyle>
+            <a:lvl1pPr>
+              <a:defRPr sz="1000">
+                <a:solidFill>
+                  <a:schemeClr val="accent5"/>
+                </a:solidFill>
+              </a:defRPr>
+            </a:lvl1pPr>
+          </a:lstStyle>
+          <a:p>
+            <a:pPr algn="r"/>
+            <a:fld id="{F7021451-1387-4CA6-816F-3879F97B5CBC}" type="slidenum">
+              <a:rPr b="0" lang="en-US"/>
+              <a:t>6</a:t>
+            </a:fld>
+            <a:endParaRPr lang="en-US"/>
+          </a:p>
+        </p:txBody>
+      </p:sp>
+    </p:spTree>
+  </p:cSld>
+  <p:clrMapOvr>
+    <a:masterClrMapping/>
+  </p:clrMapOvr>
+</p:sld>
+</file>
+
+<file path=ppt/slides/slide9.xml><?xml version="1.0" encoding="utf-8"?>
+<p:sld xmlns:a="http://schemas.openxmlformats.org/drawingml/2006/main" xmlns:r="http://schemas.openxmlformats.org/officeDocument/2006/relationships" xmlns:p="http://schemas.openxmlformats.org/presentationml/2006/main">
+  <p:cSld name="Slide 5">
+    <p:spTree>
+      <p:nvGrpSpPr>
+        <p:cNvPr id="1" name=""/>
+        <p:cNvGrpSpPr/>
+        <p:nvPr/>
+      </p:nvGrpSpPr>
+      <p:grpSpPr>
+        <a:xfrm>
+          <a:off x="0" y="0"/>
+          <a:ext cx="0" cy="0"/>
+          <a:chOff x="0" y="0"/>
+          <a:chExt cx="0" cy="0"/>
+        </a:xfrm>
+      </p:grpSpPr>
+      <p:sp>
+        <p:nvSpPr>
+          <p:cNvPr id="2" name="Text 0"/>
+          <p:cNvSpPr/>
+          <p:nvPr>
+            <p:ph idx="100" type="title" hasCustomPrompt="1"/>
+          </p:nvPr>
+        </p:nvSpPr>
+        <p:spPr>
+          <a:xfrm>
+            <a:off x="548640" y="411480"/>
+            <a:ext cx="11091672" cy="868680"/>
+          </a:xfrm>
+          <a:prstGeom prst="rect">
+            <a:avLst/>
+          </a:prstGeom>
+          <a:noFill/>
+          <a:ln/>
+        </p:spPr>
+        <p:txBody>
+          <a:bodyPr wrap="square" lIns="0" tIns="0" rIns="0" bIns="0" rtlCol="0" anchor="ctr"/>
+          <a:lstStyle/>
+          <a:p>
+            <a:pPr algn="l" indent="0" marL="0">
+              <a:buNone/>
+            </a:pPr>
+            <a:r>
+              <a:rPr lang="en-US" sz="3600" b="1" dirty="0">
+                <a:solidFill>
+                  <a:schemeClr val="tx1"/>
+                </a:solidFill>
+              </a:rPr>
+              <a:t>10월, 화면 값의 정확도를 높였습니다</a:t>
+            </a:r>
+            <a:endParaRPr lang="en-US" sz="3600" dirty="0"/>
+          </a:p>
+        </p:txBody>
+      </p:sp>
+      <p:sp>
+        <p:nvSpPr>
+          <p:cNvPr id="3" name="text-59"/>
+          <p:cNvSpPr txBox="1"/>
+          <p:nvPr/>
+        </p:nvSpPr>
+        <p:spPr>
+          <a:xfrm>
+            <a:off x="548640" y="1417320"/>
+            <a:ext cx="11091672" cy="365760"/>
+          </a:xfrm>
+          <a:prstGeom prst="rect">
+            <a:avLst/>
+          </a:prstGeom>
+          <a:noFill/>
+          <a:ln/>
+        </p:spPr>
+        <p:txBody>
+          <a:bodyPr wrap="square" lIns="0" tIns="0" rIns="0" bIns="0" rtlCol="0" anchor="t"/>
+          <a:lstStyle/>
+          <a:p>
+            <a:pPr indent="0" marL="0">
+              <a:buNone/>
+            </a:pPr>
+            <a:r>
+              <a:rPr lang="en-US" sz="1600" dirty="0">
+                <a:solidFill>
+                  <a:schemeClr val="tx2"/>
+                </a:solidFill>
+              </a:rPr>
+              <a:t>보고 이후 현업 문의를 바탕으로 고친 내용입니다</a:t>
+            </a:r>
+            <a:endParaRPr lang="en-US" sz="1600" dirty="0"/>
+          </a:p>
+        </p:txBody>
+      </p:sp>
+      <p:sp>
+        <p:nvSpPr>
+          <p:cNvPr id="4" name="card-60"/>
+          <p:cNvSpPr/>
+          <p:nvPr/>
+        </p:nvSpPr>
+        <p:spPr>
+          <a:xfrm>
+            <a:off x="548640" y="2011680"/>
+            <a:ext cx="5413248" cy="1828800"/>
+          </a:xfrm>
+          <a:prstGeom prst="roundRect">
+            <a:avLst>
+              <a:gd name="adj" fmla="val 6000"/>
+            </a:avLst>
+          </a:prstGeom>
+          <a:solidFill>
+            <a:schemeClr val="bg2"/>
+          </a:solidFill>
+          <a:ln w="12700">
+            <a:solidFill>
+              <a:schemeClr val="bg2"/>
+            </a:solidFill>
+            <a:prstDash val="solid"/>
+          </a:ln>
+        </p:spPr>
+      </p:sp>
+      <p:sp>
+        <p:nvSpPr>
+          <p:cNvPr id="5" name="dot-61"/>
+          <p:cNvSpPr/>
+          <p:nvPr/>
+        </p:nvSpPr>
+        <p:spPr>
+          <a:xfrm>
+            <a:off x="822960" y="2286000"/>
+            <a:ext cx="420624" cy="420624"/>
+          </a:xfrm>
+          <a:prstGeom prst="ellipse">
+            <a:avLst/>
+          </a:prstGeom>
+          <a:solidFill>
+            <a:schemeClr val="accent1"/>
+          </a:solidFill>
+          <a:ln/>
+        </p:spPr>
+        <p:txBody>
+          <a:bodyPr wrap="square" lIns="0" tIns="0" rIns="0" bIns="0" rtlCol="0" anchor="ctr"/>
+          <a:lstStyle/>
+          <a:p>
+            <a:pPr algn="ctr" indent="0" marL="0">
+              <a:buNone/>
+            </a:pPr>
+            <a:r>
+              <a:rPr lang="en-US" sz="1400" b="1" dirty="0">
+                <a:solidFill>
+                  <a:schemeClr val="bg1"/>
+                </a:solidFill>
+              </a:rPr>
+              <a:t>1</a:t>
+            </a:r>
+            <a:endParaRPr lang="en-US" sz="1400" dirty="0"/>
+          </a:p>
+        </p:txBody>
+      </p:sp>
+      <p:sp>
+        <p:nvSpPr>
+          <p:cNvPr id="6" name="text-62"/>
+          <p:cNvSpPr txBox="1"/>
+          <p:nvPr/>
+        </p:nvSpPr>
+        <p:spPr>
+          <a:xfrm>
+            <a:off x="1417320" y="2286000"/>
+            <a:ext cx="4297680" cy="420624"/>
+          </a:xfrm>
+          <a:prstGeom prst="rect">
+            <a:avLst/>
+          </a:prstGeom>
+          <a:noFill/>
+          <a:ln/>
+        </p:spPr>
+        <p:txBody>
+          <a:bodyPr wrap="square" lIns="0" tIns="0" rIns="0" bIns="0" rtlCol="0" anchor="ctr"/>
+          <a:lstStyle/>
+          <a:p>
+            <a:pPr indent="0" marL="0">
+              <a:buNone/>
+            </a:pPr>
+            <a:r>
+              <a:rPr lang="en-US" sz="2000" b="1" dirty="0">
+                <a:solidFill>
+                  <a:schemeClr val="tx1"/>
+                </a:solidFill>
+              </a:rPr>
+              <a:t>디바이스 통계</a:t>
+            </a:r>
+            <a:endParaRPr lang="en-US" sz="2000" dirty="0"/>
+          </a:p>
+        </p:txBody>
+      </p:sp>
+      <p:sp>
+        <p:nvSpPr>
+          <p:cNvPr id="7" name="text-63"/>
+          <p:cNvSpPr txBox="1"/>
+          <p:nvPr/>
+        </p:nvSpPr>
+        <p:spPr>
+          <a:xfrm>
+            <a:off x="1417320" y="2788920"/>
+            <a:ext cx="4297680" cy="320040"/>
+          </a:xfrm>
+          <a:prstGeom prst="rect">
+            <a:avLst/>
+          </a:prstGeom>
+          <a:noFill/>
+          <a:ln/>
+        </p:spPr>
+        <p:txBody>
+          <a:bodyPr wrap="square" lIns="0" tIns="0" rIns="0" bIns="0" rtlCol="0" anchor="t"/>
+          <a:lstStyle/>
+          <a:p>
+            <a:pPr indent="0" marL="0">
+              <a:buNone/>
+            </a:pPr>
+            <a:r>
+              <a:rPr lang="en-US" sz="1400" b="1" dirty="0">
+                <a:solidFill>
+                  <a:schemeClr val="accent2"/>
+                </a:solidFill>
+              </a:rPr>
+              <a:t>안 보이는 원인을 화면에서 구분</a:t>
+            </a:r>
+            <a:endParaRPr lang="en-US" sz="1400" dirty="0"/>
+          </a:p>
+        </p:txBody>
+      </p:sp>
+      <p:sp>
+        <p:nvSpPr>
+          <p:cNvPr id="8" name="text-64"/>
+          <p:cNvSpPr txBox="1"/>
+          <p:nvPr/>
+        </p:nvSpPr>
+        <p:spPr>
+          <a:xfrm>
+            <a:off x="1417320" y="3154680"/>
+            <a:ext cx="4297680" cy="548640"/>
+          </a:xfrm>
+          <a:prstGeom prst="rect">
+            <a:avLst/>
+          </a:prstGeom>
+          <a:noFill/>
+          <a:ln/>
+        </p:spPr>
+        <p:txBody>
+          <a:bodyPr wrap="square" lIns="0" tIns="0" rIns="0" bIns="0" rtlCol="0" anchor="t"/>
+          <a:lstStyle/>
+          <a:p>
+            <a:pPr indent="0" marL="0">
+              <a:buNone/>
+            </a:pPr>
+            <a:r>
+              <a:rPr lang="en-US" sz="1400" dirty="0">
+                <a:solidFill>
+                  <a:schemeClr val="tx2"/>
+                </a:solidFill>
+              </a:rPr>
+              <a:t>저장된 필터 적용 중 · 스텝 원본 자료 없음 표시, R 계열 DRAM/NAND 구분 누락 수정</a:t>
+            </a:r>
+            <a:endParaRPr lang="en-US" sz="1400" dirty="0"/>
+          </a:p>
+        </p:txBody>
+      </p:sp>
+      <p:sp>
+        <p:nvSpPr>
+          <p:cNvPr id="9" name="card-65"/>
+          <p:cNvSpPr/>
+          <p:nvPr/>
+        </p:nvSpPr>
+        <p:spPr>
+          <a:xfrm>
+            <a:off x="6227064" y="2011680"/>
+            <a:ext cx="5413248" cy="1828800"/>
+          </a:xfrm>
+          <a:prstGeom prst="roundRect">
+            <a:avLst>
+              <a:gd name="adj" fmla="val 6000"/>
+            </a:avLst>
+          </a:prstGeom>
+          <a:solidFill>
+            <a:schemeClr val="bg2"/>
+          </a:solidFill>
+          <a:ln w="12700">
+            <a:solidFill>
+              <a:schemeClr val="bg2"/>
+            </a:solidFill>
+            <a:prstDash val="solid"/>
+          </a:ln>
+        </p:spPr>
+      </p:sp>
+      <p:sp>
+        <p:nvSpPr>
+          <p:cNvPr id="10" name="dot-66"/>
+          <p:cNvSpPr/>
+          <p:nvPr/>
+        </p:nvSpPr>
+        <p:spPr>
+          <a:xfrm>
+            <a:off x="6501384" y="2286000"/>
+            <a:ext cx="420624" cy="420624"/>
+          </a:xfrm>
+          <a:prstGeom prst="ellipse">
+            <a:avLst/>
+          </a:prstGeom>
+          <a:solidFill>
+            <a:schemeClr val="accent1"/>
+          </a:solidFill>
+          <a:ln/>
+        </p:spPr>
+        <p:txBody>
+          <a:bodyPr wrap="square" lIns="0" tIns="0" rIns="0" bIns="0" rtlCol="0" anchor="ctr"/>
+          <a:lstStyle/>
+          <a:p>
+            <a:pPr algn="ctr" indent="0" marL="0">
+              <a:buNone/>
+            </a:pPr>
+            <a:r>
+              <a:rPr lang="en-US" sz="1400" b="1" dirty="0">
+                <a:solidFill>
+                  <a:schemeClr val="bg1"/>
+                </a:solidFill>
+              </a:rPr>
+              <a:t>2</a:t>
+            </a:r>
+            <a:endParaRPr lang="en-US" sz="1400" dirty="0"/>
+          </a:p>
+        </p:txBody>
+      </p:sp>
+      <p:sp>
+        <p:nvSpPr>
+          <p:cNvPr id="11" name="text-67"/>
+          <p:cNvSpPr txBox="1"/>
+          <p:nvPr/>
+        </p:nvSpPr>
+        <p:spPr>
+          <a:xfrm>
+            <a:off x="7095744" y="2286000"/>
+            <a:ext cx="4297680" cy="420624"/>
+          </a:xfrm>
+          <a:prstGeom prst="rect">
+            <a:avLst/>
+          </a:prstGeom>
+          <a:noFill/>
+          <a:ln/>
+        </p:spPr>
+        <p:txBody>
+          <a:bodyPr wrap="square" lIns="0" tIns="0" rIns="0" bIns="0" rtlCol="0" anchor="ctr"/>
+          <a:lstStyle/>
+          <a:p>
+            <a:pPr indent="0" marL="0">
+              <a:buNone/>
+            </a:pPr>
+            <a:r>
+              <a:rPr lang="en-US" sz="2000" b="1" dirty="0">
+                <a:solidFill>
+                  <a:schemeClr val="tx1"/>
+                </a:solidFill>
+              </a:rPr>
+              <a:t>Recipe 횡전개</a:t>
+            </a:r>
+            <a:endParaRPr lang="en-US" sz="2000" dirty="0"/>
+          </a:p>
+        </p:txBody>
+      </p:sp>
+      <p:sp>
+        <p:nvSpPr>
+          <p:cNvPr id="12" name="text-68"/>
+          <p:cNvSpPr txBox="1"/>
+          <p:nvPr/>
+        </p:nvSpPr>
+        <p:spPr>
+          <a:xfrm>
+            <a:off x="7095744" y="2788920"/>
+            <a:ext cx="4297680" cy="320040"/>
+          </a:xfrm>
+          <a:prstGeom prst="rect">
+            <a:avLst/>
+          </a:prstGeom>
+          <a:noFill/>
+          <a:ln/>
+        </p:spPr>
+        <p:txBody>
+          <a:bodyPr wrap="square" lIns="0" tIns="0" rIns="0" bIns="0" rtlCol="0" anchor="t"/>
+          <a:lstStyle/>
+          <a:p>
+            <a:pPr indent="0" marL="0">
+              <a:buNone/>
+            </a:pPr>
+            <a:r>
+              <a:rPr lang="en-US" sz="1400" b="1" dirty="0">
+                <a:solidFill>
+                  <a:schemeClr val="accent2"/>
+                </a:solidFill>
+              </a:rPr>
+              <a:t>보유 판정 원본 수정</a:t>
+            </a:r>
+            <a:endParaRPr lang="en-US" sz="1400" dirty="0"/>
+          </a:p>
+        </p:txBody>
+      </p:sp>
+      <p:sp>
+        <p:nvSpPr>
+          <p:cNvPr id="13" name="text-69"/>
+          <p:cNvSpPr txBox="1"/>
+          <p:nvPr/>
+        </p:nvSpPr>
+        <p:spPr>
+          <a:xfrm>
+            <a:off x="7095744" y="3154680"/>
+            <a:ext cx="4297680" cy="548640"/>
+          </a:xfrm>
+          <a:prstGeom prst="rect">
+            <a:avLst/>
+          </a:prstGeom>
+          <a:noFill/>
+          <a:ln/>
+        </p:spPr>
+        <p:txBody>
+          <a:bodyPr wrap="square" lIns="0" tIns="0" rIns="0" bIns="0" rtlCol="0" anchor="t"/>
+          <a:lstStyle/>
+          <a:p>
+            <a:pPr indent="0" marL="0">
+              <a:buNone/>
+            </a:pPr>
+            <a:r>
+              <a:rPr lang="en-US" sz="1400" dirty="0">
+                <a:solidFill>
+                  <a:schemeClr val="tx2"/>
+                </a:solidFill>
+              </a:rPr>
+              <a:t>최근 측정하지 않은 장비도 보유로 표시, 점검 실패 장비는 확인 불가 배지</a:t>
+            </a:r>
+            <a:endParaRPr lang="en-US" sz="1400" dirty="0"/>
+          </a:p>
+        </p:txBody>
+      </p:sp>
+      <p:sp>
+        <p:nvSpPr>
+          <p:cNvPr id="14" name="card-70"/>
+          <p:cNvSpPr/>
+          <p:nvPr/>
+        </p:nvSpPr>
+        <p:spPr>
+          <a:xfrm>
+            <a:off x="548640" y="4114800"/>
+            <a:ext cx="5413248" cy="1828800"/>
+          </a:xfrm>
+          <a:prstGeom prst="roundRect">
+            <a:avLst>
+              <a:gd name="adj" fmla="val 6000"/>
+            </a:avLst>
+          </a:prstGeom>
+          <a:solidFill>
+            <a:schemeClr val="bg2"/>
+          </a:solidFill>
+          <a:ln w="12700">
+            <a:solidFill>
+              <a:schemeClr val="bg2"/>
+            </a:solidFill>
+            <a:prstDash val="solid"/>
+          </a:ln>
+        </p:spPr>
+      </p:sp>
+      <p:sp>
+        <p:nvSpPr>
+          <p:cNvPr id="15" name="dot-71"/>
+          <p:cNvSpPr/>
+          <p:nvPr/>
+        </p:nvSpPr>
+        <p:spPr>
+          <a:xfrm>
+            <a:off x="822960" y="4389120"/>
+            <a:ext cx="420624" cy="420624"/>
+          </a:xfrm>
+          <a:prstGeom prst="ellipse">
+            <a:avLst/>
+          </a:prstGeom>
+          <a:solidFill>
+            <a:schemeClr val="accent1"/>
+          </a:solidFill>
+          <a:ln/>
+        </p:spPr>
+        <p:txBody>
+          <a:bodyPr wrap="square" lIns="0" tIns="0" rIns="0" bIns="0" rtlCol="0" anchor="ctr"/>
+          <a:lstStyle/>
+          <a:p>
+            <a:pPr algn="ctr" indent="0" marL="0">
+              <a:buNone/>
+            </a:pPr>
+            <a:r>
+              <a:rPr lang="en-US" sz="1400" b="1" dirty="0">
+                <a:solidFill>
+                  <a:schemeClr val="bg1"/>
+                </a:solidFill>
+              </a:rPr>
+              <a:t>3</a:t>
+            </a:r>
+            <a:endParaRPr lang="en-US" sz="1400" dirty="0"/>
+          </a:p>
+        </p:txBody>
+      </p:sp>
+      <p:sp>
+        <p:nvSpPr>
+          <p:cNvPr id="16" name="text-72"/>
+          <p:cNvSpPr txBox="1"/>
+          <p:nvPr/>
+        </p:nvSpPr>
+        <p:spPr>
+          <a:xfrm>
+            <a:off x="1417320" y="4389120"/>
+            <a:ext cx="4297680" cy="420624"/>
+          </a:xfrm>
+          <a:prstGeom prst="rect">
+            <a:avLst/>
+          </a:prstGeom>
+          <a:noFill/>
+          <a:ln/>
+        </p:spPr>
+        <p:txBody>
+          <a:bodyPr wrap="square" lIns="0" tIns="0" rIns="0" bIns="0" rtlCol="0" anchor="ctr"/>
+          <a:lstStyle/>
+          <a:p>
+            <a:pPr indent="0" marL="0">
+              <a:buNone/>
+            </a:pPr>
+            <a:r>
+              <a:rPr lang="en-US" sz="2000" b="1" dirty="0">
+                <a:solidFill>
+                  <a:schemeClr val="tx1"/>
+                </a:solidFill>
+              </a:rPr>
+              <a:t>Recipe 현황</a:t>
+            </a:r>
+            <a:endParaRPr lang="en-US" sz="2000" dirty="0"/>
+          </a:p>
+        </p:txBody>
+      </p:sp>
+      <p:sp>
+        <p:nvSpPr>
+          <p:cNvPr id="17" name="text-73"/>
+          <p:cNvSpPr txBox="1"/>
+          <p:nvPr/>
+        </p:nvSpPr>
+        <p:spPr>
+          <a:xfrm>
+            <a:off x="1417320" y="4892040"/>
+            <a:ext cx="4297680" cy="320040"/>
+          </a:xfrm>
+          <a:prstGeom prst="rect">
+            <a:avLst/>
+          </a:prstGeom>
+          <a:noFill/>
+          <a:ln/>
+        </p:spPr>
+        <p:txBody>
+          <a:bodyPr wrap="square" lIns="0" tIns="0" rIns="0" bIns="0" rtlCol="0" anchor="t"/>
+          <a:lstStyle/>
+          <a:p>
+            <a:pPr indent="0" marL="0">
+              <a:buNone/>
+            </a:pPr>
+            <a:r>
+              <a:rPr lang="en-US" sz="1400" b="1" dirty="0">
+                <a:solidFill>
+                  <a:schemeClr val="accent2"/>
+                </a:solidFill>
+              </a:rPr>
+              <a:t>데이터 누락 수정</a:t>
+            </a:r>
+            <a:endParaRPr lang="en-US" sz="1400" dirty="0"/>
+          </a:p>
+        </p:txBody>
+      </p:sp>
+      <p:sp>
+        <p:nvSpPr>
+          <p:cNvPr id="18" name="text-74"/>
+          <p:cNvSpPr txBox="1"/>
+          <p:nvPr/>
+        </p:nvSpPr>
+        <p:spPr>
+          <a:xfrm>
+            <a:off x="1417320" y="5257800"/>
+            <a:ext cx="4297680" cy="548640"/>
+          </a:xfrm>
+          <a:prstGeom prst="rect">
+            <a:avLst/>
+          </a:prstGeom>
+          <a:noFill/>
+          <a:ln/>
+        </p:spPr>
+        <p:txBody>
+          <a:bodyPr wrap="square" lIns="0" tIns="0" rIns="0" bIns="0" rtlCol="0" anchor="t"/>
+          <a:lstStyle/>
+          <a:p>
+            <a:pPr indent="0" marL="0">
+              <a:buNone/>
+            </a:pPr>
+            <a:r>
+              <a:rPr lang="en-US" sz="1400" dirty="0">
+                <a:solidFill>
+                  <a:schemeClr val="tx2"/>
+                </a:solidFill>
+              </a:rPr>
+              <a:t>이력이 많은 조회에서 결과가 빠지거나 응답이 끊기던 문제 해결</a:t>
+            </a:r>
+            <a:endParaRPr lang="en-US" sz="1400" dirty="0"/>
+          </a:p>
+        </p:txBody>
+      </p:sp>
+      <p:sp>
+        <p:nvSpPr>
+          <p:cNvPr id="19" name="card-75"/>
+          <p:cNvSpPr/>
+          <p:nvPr/>
+        </p:nvSpPr>
+        <p:spPr>
+          <a:xfrm>
+            <a:off x="6227064" y="4114800"/>
+            <a:ext cx="5413248" cy="1828800"/>
+          </a:xfrm>
+          <a:prstGeom prst="roundRect">
+            <a:avLst>
+              <a:gd name="adj" fmla="val 6000"/>
+            </a:avLst>
+          </a:prstGeom>
+          <a:solidFill>
+            <a:schemeClr val="bg2"/>
+          </a:solidFill>
+          <a:ln w="12700">
+            <a:solidFill>
+              <a:schemeClr val="bg2"/>
+            </a:solidFill>
+            <a:prstDash val="solid"/>
+          </a:ln>
+        </p:spPr>
+      </p:sp>
+      <p:sp>
+        <p:nvSpPr>
+          <p:cNvPr id="20" name="dot-76"/>
+          <p:cNvSpPr/>
+          <p:nvPr/>
+        </p:nvSpPr>
+        <p:spPr>
+          <a:xfrm>
+            <a:off x="6501384" y="4389120"/>
+            <a:ext cx="420624" cy="420624"/>
+          </a:xfrm>
+          <a:prstGeom prst="ellipse">
+            <a:avLst/>
+          </a:prstGeom>
+          <a:solidFill>
+            <a:schemeClr val="accent1"/>
+          </a:solidFill>
+          <a:ln/>
+        </p:spPr>
+        <p:txBody>
+          <a:bodyPr wrap="square" lIns="0" tIns="0" rIns="0" bIns="0" rtlCol="0" anchor="ctr"/>
+          <a:lstStyle/>
+          <a:p>
+            <a:pPr algn="ctr" indent="0" marL="0">
+              <a:buNone/>
+            </a:pPr>
+            <a:r>
+              <a:rPr lang="en-US" sz="1400" b="1" dirty="0">
+                <a:solidFill>
+                  <a:schemeClr val="bg1"/>
+                </a:solidFill>
+              </a:rPr>
+              <a:t>4</a:t>
+            </a:r>
+            <a:endParaRPr lang="en-US" sz="1400" dirty="0"/>
+          </a:p>
+        </p:txBody>
+      </p:sp>
+      <p:sp>
+        <p:nvSpPr>
+          <p:cNvPr id="21" name="text-77"/>
+          <p:cNvSpPr txBox="1"/>
+          <p:nvPr/>
+        </p:nvSpPr>
+        <p:spPr>
+          <a:xfrm>
+            <a:off x="7095744" y="4389120"/>
+            <a:ext cx="4297680" cy="420624"/>
+          </a:xfrm>
+          <a:prstGeom prst="rect">
+            <a:avLst/>
+          </a:prstGeom>
+          <a:noFill/>
+          <a:ln/>
+        </p:spPr>
+        <p:txBody>
+          <a:bodyPr wrap="square" lIns="0" tIns="0" rIns="0" bIns="0" rtlCol="0" anchor="ctr"/>
+          <a:lstStyle/>
+          <a:p>
+            <a:pPr indent="0" marL="0">
+              <a:buNone/>
+            </a:pPr>
+            <a:r>
+              <a:rPr lang="en-US" sz="2000" b="1" dirty="0">
+                <a:solidFill>
+                  <a:schemeClr val="tx1"/>
+                </a:solidFill>
+              </a:rPr>
+              <a:t>AFM · 운영</a:t>
+            </a:r>
+            <a:endParaRPr lang="en-US" sz="2000" dirty="0"/>
+          </a:p>
+        </p:txBody>
+      </p:sp>
+      <p:sp>
+        <p:nvSpPr>
+          <p:cNvPr id="22" name="text-78"/>
+          <p:cNvSpPr txBox="1"/>
+          <p:nvPr/>
+        </p:nvSpPr>
+        <p:spPr>
+          <a:xfrm>
+            <a:off x="7095744" y="4892040"/>
+            <a:ext cx="4297680" cy="320040"/>
+          </a:xfrm>
+          <a:prstGeom prst="rect">
+            <a:avLst/>
+          </a:prstGeom>
+          <a:noFill/>
+          <a:ln/>
+        </p:spPr>
+        <p:txBody>
+          <a:bodyPr wrap="square" lIns="0" tIns="0" rIns="0" bIns="0" rtlCol="0" anchor="t"/>
+          <a:lstStyle/>
+          <a:p>
+            <a:pPr indent="0" marL="0">
+              <a:buNone/>
+            </a:pPr>
+            <a:r>
+              <a:rPr lang="en-US" sz="1400" b="1" dirty="0">
+                <a:solidFill>
+                  <a:schemeClr val="accent2"/>
+                </a:solidFill>
+              </a:rPr>
+              <a:t>응답 경량화 · 로그 보강</a:t>
+            </a:r>
+            <a:endParaRPr lang="en-US" sz="1400" dirty="0"/>
+          </a:p>
+        </p:txBody>
+      </p:sp>
+      <p:sp>
+        <p:nvSpPr>
+          <p:cNvPr id="23" name="text-79"/>
+          <p:cNvSpPr txBox="1"/>
+          <p:nvPr/>
+        </p:nvSpPr>
+        <p:spPr>
+          <a:xfrm>
+            <a:off x="7095744" y="5257800"/>
+            <a:ext cx="4297680" cy="548640"/>
+          </a:xfrm>
+          <a:prstGeom prst="rect">
+            <a:avLst/>
+          </a:prstGeom>
+          <a:noFill/>
+          <a:ln/>
+        </p:spPr>
+        <p:txBody>
+          <a:bodyPr wrap="square" lIns="0" tIns="0" rIns="0" bIns="0" rtlCol="0" anchor="t"/>
+          <a:lstStyle/>
+          <a:p>
+            <a:pPr indent="0" marL="0">
+              <a:buNone/>
+            </a:pPr>
+            <a:r>
+              <a:rPr lang="en-US" sz="1400" dirty="0">
+                <a:solidFill>
+                  <a:schemeClr val="tx2"/>
+                </a:solidFill>
+              </a:rPr>
+              <a:t>AFM 측정 목록 응답 경량화, 요청 로그에 오류 원인과 호출 화면 기록</a:t>
+            </a:r>
+            <a:endParaRPr lang="en-US" sz="1400" dirty="0"/>
+          </a:p>
+        </p:txBody>
+      </p:sp>
+      <p:sp>
+        <p:nvSpPr>
+          <p:cNvPr id="25" name="Slide Number Placeholder 0"/>
+          <p:cNvSpPr>
+            <a:spLocks noGrp="1"/>
+          </p:cNvSpPr>
+          <p:nvPr>
+            <p:ph type="sldNum" sz="quarter" idx="4294967295"/>
+          </p:nvPr>
+        </p:nvSpPr>
+        <p:spPr>
+          <a:xfrm>
+            <a:off x="11091672" y="6400800"/>
+            <a:ext cx="548640" cy="274320"/>
+          </a:xfrm>
+          <a:prstGeom prst="rect">
+            <a:avLst/>
+          </a:prstGeom>
+          <a:extLst>
+            <a:ext uri="{C572A759-6A51-4108-AA02-DFA0A04FC94B}">
+              <ma14:wrappingTextBoxFlag xmlns:ma14="http://schemas.microsoft.com/office/mac/drawingml/2011/main" val="0"/>
+            </a:ext>
+          </a:extLst>
+        </p:spPr>
+        <p:txBody>
+          <a:bodyPr/>
+          <a:lstStyle>
+            <a:lvl1pPr>
+              <a:defRPr sz="1000">
+                <a:solidFill>
+                  <a:schemeClr val="accent5"/>
+                </a:solidFill>
+              </a:defRPr>
+            </a:lvl1pPr>
+          </a:lstStyle>
+          <a:p>
+            <a:pPr algn="r"/>
+            <a:fld id="{F7021451-1387-4CA6-816F-3879F97B5CBC}" type="slidenum">
+              <a:rPr b="0" lang="en-US"/>
+              <a:t>5</a:t>
+            </a:fld>
+            <a:endParaRPr lang="en-US"/>
           </a:p>
         </p:txBody>
       </p:sp>

</xml_diff>